<commit_message>
WIP: Chemistry U2 deck fix round (S2.4 fixed; S2.2, S2.3, S2.5 in progress)
Co-Authored-By: Claude Sonnet 5.5 <noreply@anthropic.com>
Claude-Session: https://claude.ai/code/session_01CAqidLLu6PiYNMcZx5qMsE
</commit_message>
<xml_diff>
--- a/deliverables/chem-u02/SHULL_CHEM_Slides_U02_S02.2.pptx
+++ b/deliverables/chem-u02/SHULL_CHEM_Slides_U02_S02.2.pptx
@@ -17948,24 +17948,7 @@
                 <a:ea typeface="Trade Gothic Next" pitchFamily="34" charset="-122"/>
                 <a:cs typeface="Trade Gothic Next" pitchFamily="34" charset="-120"/>
               </a:rPr>
-              <a:t>d: groups 3 to 12, 10 wide.</a:t>
-            </a:r>
-            <a:endParaRPr lang="en-US" sz="1600" dirty="0"/>
-          </a:p>
-          <a:p>
-            <a:pPr indent="0" marL="0">
-              <a:buNone/>
-            </a:pPr>
-            <a:r>
-              <a:rPr lang="en-US" sz="1600" dirty="0">
-                <a:solidFill>
-                  <a:srgbClr val="14161B"/>
-                </a:solidFill>
-                <a:latin typeface="Trade Gothic Next" pitchFamily="34" charset="0"/>
-                <a:ea typeface="Trade Gothic Next" pitchFamily="34" charset="-122"/>
-                <a:cs typeface="Trade Gothic Next" pitchFamily="34" charset="-120"/>
-              </a:rPr>
-              <a:t>f: 14 wide, drawn below the table.</a:t>
+              <a:t>d: groups 3 to 12. f: drawn below, 14 wide.</a:t>
             </a:r>
             <a:endParaRPr lang="en-US" sz="1600" dirty="0"/>
           </a:p>
@@ -23008,7 +22991,7 @@
                 <a:ea typeface="Trade Gothic Next" pitchFamily="34" charset="-122"/>
                 <a:cs typeface="Trade Gothic Next" pitchFamily="34" charset="-120"/>
               </a:rPr>
-              <a:t>d: five orbitals, mostly four lobes. f: more complex.</a:t>
+              <a:t>d starts at n = 3. f starts at n = 4.</a:t>
             </a:r>
             <a:endParaRPr lang="en-US" sz="1600" dirty="0"/>
           </a:p>
@@ -23497,7 +23480,7 @@
                 <a:ea typeface="Trade Gothic Next" pitchFamily="34" charset="-122"/>
                 <a:cs typeface="Trade Gothic Next" pitchFamily="34" charset="-120"/>
               </a:rPr>
-              <a:t>d: mostly four lobes. f: more complex.</a:t>
+              <a:t>d: five orbitals, mostly four lobes. f: more complex.</a:t>
             </a:r>
             <a:endParaRPr lang="en-US" sz="1600" dirty="0"/>
           </a:p>

</xml_diff>